<commit_message>
Add email approval workflow: require explicit approval before sending, show recipient info (account, industry, location, IT spend)
</commit_message>
<xml_diff>
--- a/RevFlare-Presentation.pptx
+++ b/RevFlare-Presentation.pptx
@@ -6700,7 +6700,7 @@
               </a:defRPr>
             </a:pPr>
             <a:r>
-              <a:t>15 Features + Competitive Intelligence</a:t>
+              <a:t>16 Features + Competitive Intelligence</a:t>
             </a:r>
           </a:p>
         </p:txBody>
@@ -6714,7 +6714,7 @@
         <p:spPr>
           <a:xfrm>
             <a:off x="457200" y="1234440"/>
-            <a:ext cx="1371600" cy="731520"/>
+            <a:ext cx="1371600" cy="640080"/>
           </a:xfrm>
           <a:prstGeom prst="roundRect">
             <a:avLst/>
@@ -6799,7 +6799,7 @@
         </p:nvSpPr>
         <p:spPr>
           <a:xfrm>
-            <a:off x="530352" y="1344168"/>
+            <a:off x="530352" y="1307592"/>
             <a:ext cx="1234440" cy="201168"/>
           </a:xfrm>
           <a:prstGeom prst="rect">
@@ -6835,7 +6835,7 @@
         </p:nvSpPr>
         <p:spPr>
           <a:xfrm>
-            <a:off x="530352" y="1581912"/>
+            <a:off x="530352" y="1527048"/>
             <a:ext cx="1234440" cy="274320"/>
           </a:xfrm>
           <a:prstGeom prst="rect">
@@ -6872,7 +6872,7 @@
         <p:spPr>
           <a:xfrm>
             <a:off x="1965960" y="1234440"/>
-            <a:ext cx="1371600" cy="731520"/>
+            <a:ext cx="1371600" cy="640080"/>
           </a:xfrm>
           <a:prstGeom prst="roundRect">
             <a:avLst/>
@@ -6957,7 +6957,7 @@
         </p:nvSpPr>
         <p:spPr>
           <a:xfrm>
-            <a:off x="2039112" y="1344168"/>
+            <a:off x="2039112" y="1307592"/>
             <a:ext cx="1234440" cy="201168"/>
           </a:xfrm>
           <a:prstGeom prst="rect">
@@ -6993,7 +6993,7 @@
         </p:nvSpPr>
         <p:spPr>
           <a:xfrm>
-            <a:off x="2039112" y="1581912"/>
+            <a:off x="2039112" y="1527048"/>
             <a:ext cx="1234440" cy="274320"/>
           </a:xfrm>
           <a:prstGeom prst="rect">
@@ -7030,7 +7030,7 @@
         <p:spPr>
           <a:xfrm>
             <a:off x="3474720" y="1234440"/>
-            <a:ext cx="1371600" cy="731520"/>
+            <a:ext cx="1371600" cy="640080"/>
           </a:xfrm>
           <a:prstGeom prst="roundRect">
             <a:avLst/>
@@ -7115,7 +7115,7 @@
         </p:nvSpPr>
         <p:spPr>
           <a:xfrm>
-            <a:off x="3547872" y="1344168"/>
+            <a:off x="3547872" y="1307592"/>
             <a:ext cx="1234440" cy="201168"/>
           </a:xfrm>
           <a:prstGeom prst="rect">
@@ -7151,7 +7151,7 @@
         </p:nvSpPr>
         <p:spPr>
           <a:xfrm>
-            <a:off x="3547872" y="1581912"/>
+            <a:off x="3547872" y="1527048"/>
             <a:ext cx="1234440" cy="274320"/>
           </a:xfrm>
           <a:prstGeom prst="rect">
@@ -7188,7 +7188,7 @@
         <p:spPr>
           <a:xfrm>
             <a:off x="4983479" y="1234440"/>
-            <a:ext cx="1371600" cy="731520"/>
+            <a:ext cx="1371600" cy="640080"/>
           </a:xfrm>
           <a:prstGeom prst="roundRect">
             <a:avLst/>
@@ -7273,7 +7273,7 @@
         </p:nvSpPr>
         <p:spPr>
           <a:xfrm>
-            <a:off x="5056631" y="1344168"/>
+            <a:off x="5056631" y="1307592"/>
             <a:ext cx="1234440" cy="201168"/>
           </a:xfrm>
           <a:prstGeom prst="rect">
@@ -7309,7 +7309,7 @@
         </p:nvSpPr>
         <p:spPr>
           <a:xfrm>
-            <a:off x="5056631" y="1581912"/>
+            <a:off x="5056631" y="1527048"/>
             <a:ext cx="1234440" cy="274320"/>
           </a:xfrm>
           <a:prstGeom prst="rect">
@@ -7346,7 +7346,7 @@
         <p:spPr>
           <a:xfrm>
             <a:off x="6492240" y="1234440"/>
-            <a:ext cx="1371600" cy="731520"/>
+            <a:ext cx="1371600" cy="640080"/>
           </a:xfrm>
           <a:prstGeom prst="roundRect">
             <a:avLst/>
@@ -7431,7 +7431,7 @@
         </p:nvSpPr>
         <p:spPr>
           <a:xfrm>
-            <a:off x="6565392" y="1344168"/>
+            <a:off x="6565392" y="1307592"/>
             <a:ext cx="1234440" cy="201168"/>
           </a:xfrm>
           <a:prstGeom prst="rect">
@@ -7467,7 +7467,7 @@
         </p:nvSpPr>
         <p:spPr>
           <a:xfrm>
-            <a:off x="6565392" y="1581912"/>
+            <a:off x="6565392" y="1527048"/>
             <a:ext cx="1234440" cy="274320"/>
           </a:xfrm>
           <a:prstGeom prst="rect">
@@ -7503,8 +7503,8 @@
         </p:nvSpPr>
         <p:spPr>
           <a:xfrm>
-            <a:off x="457200" y="2103120"/>
-            <a:ext cx="1371600" cy="731520"/>
+            <a:off x="457200" y="2011680"/>
+            <a:ext cx="1371600" cy="640080"/>
           </a:xfrm>
           <a:prstGeom prst="roundRect">
             <a:avLst/>
@@ -7546,7 +7546,7 @@
         </p:nvSpPr>
         <p:spPr>
           <a:xfrm>
-            <a:off x="457200" y="2103120"/>
+            <a:off x="457200" y="2011680"/>
             <a:ext cx="1371600" cy="38100"/>
           </a:xfrm>
           <a:prstGeom prst="rect">
@@ -7589,7 +7589,7 @@
         </p:nvSpPr>
         <p:spPr>
           <a:xfrm>
-            <a:off x="530352" y="2212848"/>
+            <a:off x="530352" y="2084832"/>
             <a:ext cx="1234440" cy="201168"/>
           </a:xfrm>
           <a:prstGeom prst="rect">
@@ -7625,7 +7625,7 @@
         </p:nvSpPr>
         <p:spPr>
           <a:xfrm>
-            <a:off x="530352" y="2450592"/>
+            <a:off x="530352" y="2304288"/>
             <a:ext cx="1234440" cy="274320"/>
           </a:xfrm>
           <a:prstGeom prst="rect">
@@ -7661,8 +7661,8 @@
         </p:nvSpPr>
         <p:spPr>
           <a:xfrm>
-            <a:off x="1965960" y="2103120"/>
-            <a:ext cx="1371600" cy="731520"/>
+            <a:off x="1965960" y="2011680"/>
+            <a:ext cx="1371600" cy="640080"/>
           </a:xfrm>
           <a:prstGeom prst="roundRect">
             <a:avLst/>
@@ -7704,7 +7704,7 @@
         </p:nvSpPr>
         <p:spPr>
           <a:xfrm>
-            <a:off x="1965960" y="2103120"/>
+            <a:off x="1965960" y="2011680"/>
             <a:ext cx="1371600" cy="38100"/>
           </a:xfrm>
           <a:prstGeom prst="rect">
@@ -7747,7 +7747,7 @@
         </p:nvSpPr>
         <p:spPr>
           <a:xfrm>
-            <a:off x="2039112" y="2212848"/>
+            <a:off x="2039112" y="2084832"/>
             <a:ext cx="1234440" cy="201168"/>
           </a:xfrm>
           <a:prstGeom prst="rect">
@@ -7783,7 +7783,7 @@
         </p:nvSpPr>
         <p:spPr>
           <a:xfrm>
-            <a:off x="2039112" y="2450592"/>
+            <a:off x="2039112" y="2304288"/>
             <a:ext cx="1234440" cy="274320"/>
           </a:xfrm>
           <a:prstGeom prst="rect">
@@ -7819,8 +7819,8 @@
         </p:nvSpPr>
         <p:spPr>
           <a:xfrm>
-            <a:off x="3474720" y="2103120"/>
-            <a:ext cx="1371600" cy="731520"/>
+            <a:off x="3474720" y="2011680"/>
+            <a:ext cx="1371600" cy="640080"/>
           </a:xfrm>
           <a:prstGeom prst="roundRect">
             <a:avLst/>
@@ -7862,7 +7862,7 @@
         </p:nvSpPr>
         <p:spPr>
           <a:xfrm>
-            <a:off x="3474720" y="2103120"/>
+            <a:off x="3474720" y="2011680"/>
             <a:ext cx="1371600" cy="38100"/>
           </a:xfrm>
           <a:prstGeom prst="rect">
@@ -7905,7 +7905,7 @@
         </p:nvSpPr>
         <p:spPr>
           <a:xfrm>
-            <a:off x="3547872" y="2212848"/>
+            <a:off x="3547872" y="2084832"/>
             <a:ext cx="1234440" cy="201168"/>
           </a:xfrm>
           <a:prstGeom prst="rect">
@@ -7941,7 +7941,7 @@
         </p:nvSpPr>
         <p:spPr>
           <a:xfrm>
-            <a:off x="3547872" y="2450592"/>
+            <a:off x="3547872" y="2304288"/>
             <a:ext cx="1234440" cy="274320"/>
           </a:xfrm>
           <a:prstGeom prst="rect">
@@ -7977,8 +7977,8 @@
         </p:nvSpPr>
         <p:spPr>
           <a:xfrm>
-            <a:off x="4983479" y="2103120"/>
-            <a:ext cx="1371600" cy="731520"/>
+            <a:off x="4983479" y="2011680"/>
+            <a:ext cx="1371600" cy="640080"/>
           </a:xfrm>
           <a:prstGeom prst="roundRect">
             <a:avLst/>
@@ -8020,7 +8020,7 @@
         </p:nvSpPr>
         <p:spPr>
           <a:xfrm>
-            <a:off x="4983479" y="2103120"/>
+            <a:off x="4983479" y="2011680"/>
             <a:ext cx="1371600" cy="38100"/>
           </a:xfrm>
           <a:prstGeom prst="rect">
@@ -8063,7 +8063,7 @@
         </p:nvSpPr>
         <p:spPr>
           <a:xfrm>
-            <a:off x="5056631" y="2212848"/>
+            <a:off x="5056631" y="2084832"/>
             <a:ext cx="1234440" cy="201168"/>
           </a:xfrm>
           <a:prstGeom prst="rect">
@@ -8099,7 +8099,7 @@
         </p:nvSpPr>
         <p:spPr>
           <a:xfrm>
-            <a:off x="5056631" y="2450592"/>
+            <a:off x="5056631" y="2304288"/>
             <a:ext cx="1234440" cy="274320"/>
           </a:xfrm>
           <a:prstGeom prst="rect">
@@ -8135,8 +8135,8 @@
         </p:nvSpPr>
         <p:spPr>
           <a:xfrm>
-            <a:off x="6492240" y="2103120"/>
-            <a:ext cx="1371600" cy="731520"/>
+            <a:off x="6492240" y="2011680"/>
+            <a:ext cx="1371600" cy="640080"/>
           </a:xfrm>
           <a:prstGeom prst="roundRect">
             <a:avLst/>
@@ -8178,7 +8178,7 @@
         </p:nvSpPr>
         <p:spPr>
           <a:xfrm>
-            <a:off x="6492240" y="2103120"/>
+            <a:off x="6492240" y="2011680"/>
             <a:ext cx="1371600" cy="38100"/>
           </a:xfrm>
           <a:prstGeom prst="rect">
@@ -8221,7 +8221,7 @@
         </p:nvSpPr>
         <p:spPr>
           <a:xfrm>
-            <a:off x="6565392" y="2212848"/>
+            <a:off x="6565392" y="2084832"/>
             <a:ext cx="1234440" cy="201168"/>
           </a:xfrm>
           <a:prstGeom prst="rect">
@@ -8257,7 +8257,7 @@
         </p:nvSpPr>
         <p:spPr>
           <a:xfrm>
-            <a:off x="6565392" y="2450592"/>
+            <a:off x="6565392" y="2304288"/>
             <a:ext cx="1234440" cy="274320"/>
           </a:xfrm>
           <a:prstGeom prst="rect">
@@ -8293,8 +8293,8 @@
         </p:nvSpPr>
         <p:spPr>
           <a:xfrm>
-            <a:off x="457200" y="2971800"/>
-            <a:ext cx="1371600" cy="731520"/>
+            <a:off x="457200" y="2788920"/>
+            <a:ext cx="1371600" cy="640080"/>
           </a:xfrm>
           <a:prstGeom prst="roundRect">
             <a:avLst/>
@@ -8336,7 +8336,7 @@
         </p:nvSpPr>
         <p:spPr>
           <a:xfrm>
-            <a:off x="457200" y="2971800"/>
+            <a:off x="457200" y="2788920"/>
             <a:ext cx="1371600" cy="38100"/>
           </a:xfrm>
           <a:prstGeom prst="rect">
@@ -8379,7 +8379,7 @@
         </p:nvSpPr>
         <p:spPr>
           <a:xfrm>
-            <a:off x="530352" y="3081528"/>
+            <a:off x="530352" y="2862072"/>
             <a:ext cx="1234440" cy="201168"/>
           </a:xfrm>
           <a:prstGeom prst="rect">
@@ -8415,7 +8415,7 @@
         </p:nvSpPr>
         <p:spPr>
           <a:xfrm>
-            <a:off x="530352" y="3319272"/>
+            <a:off x="530352" y="3081528"/>
             <a:ext cx="1234440" cy="274320"/>
           </a:xfrm>
           <a:prstGeom prst="rect">
@@ -8451,8 +8451,8 @@
         </p:nvSpPr>
         <p:spPr>
           <a:xfrm>
-            <a:off x="1965960" y="2971800"/>
-            <a:ext cx="1371600" cy="731520"/>
+            <a:off x="1965960" y="2788920"/>
+            <a:ext cx="1371600" cy="640080"/>
           </a:xfrm>
           <a:prstGeom prst="roundRect">
             <a:avLst/>
@@ -8494,7 +8494,7 @@
         </p:nvSpPr>
         <p:spPr>
           <a:xfrm>
-            <a:off x="1965960" y="2971800"/>
+            <a:off x="1965960" y="2788920"/>
             <a:ext cx="1371600" cy="38100"/>
           </a:xfrm>
           <a:prstGeom prst="rect">
@@ -8537,7 +8537,7 @@
         </p:nvSpPr>
         <p:spPr>
           <a:xfrm>
-            <a:off x="2039112" y="3081528"/>
+            <a:off x="2039112" y="2862072"/>
             <a:ext cx="1234440" cy="201168"/>
           </a:xfrm>
           <a:prstGeom prst="rect">
@@ -8573,7 +8573,7 @@
         </p:nvSpPr>
         <p:spPr>
           <a:xfrm>
-            <a:off x="2039112" y="3319272"/>
+            <a:off x="2039112" y="3081528"/>
             <a:ext cx="1234440" cy="274320"/>
           </a:xfrm>
           <a:prstGeom prst="rect">
@@ -8609,8 +8609,8 @@
         </p:nvSpPr>
         <p:spPr>
           <a:xfrm>
-            <a:off x="3474720" y="2971800"/>
-            <a:ext cx="1371600" cy="731520"/>
+            <a:off x="3474720" y="2788920"/>
+            <a:ext cx="1371600" cy="640080"/>
           </a:xfrm>
           <a:prstGeom prst="roundRect">
             <a:avLst/>
@@ -8652,7 +8652,7 @@
         </p:nvSpPr>
         <p:spPr>
           <a:xfrm>
-            <a:off x="3474720" y="2971800"/>
+            <a:off x="3474720" y="2788920"/>
             <a:ext cx="1371600" cy="38100"/>
           </a:xfrm>
           <a:prstGeom prst="rect">
@@ -8695,7 +8695,7 @@
         </p:nvSpPr>
         <p:spPr>
           <a:xfrm>
-            <a:off x="3547872" y="3081528"/>
+            <a:off x="3547872" y="2862072"/>
             <a:ext cx="1234440" cy="201168"/>
           </a:xfrm>
           <a:prstGeom prst="rect">
@@ -8731,7 +8731,7 @@
         </p:nvSpPr>
         <p:spPr>
           <a:xfrm>
-            <a:off x="3547872" y="3319272"/>
+            <a:off x="3547872" y="3081528"/>
             <a:ext cx="1234440" cy="274320"/>
           </a:xfrm>
           <a:prstGeom prst="rect">
@@ -8767,8 +8767,8 @@
         </p:nvSpPr>
         <p:spPr>
           <a:xfrm>
-            <a:off x="4983479" y="2971800"/>
-            <a:ext cx="1371600" cy="731520"/>
+            <a:off x="4983479" y="2788920"/>
+            <a:ext cx="1371600" cy="640080"/>
           </a:xfrm>
           <a:prstGeom prst="roundRect">
             <a:avLst/>
@@ -8810,7 +8810,7 @@
         </p:nvSpPr>
         <p:spPr>
           <a:xfrm>
-            <a:off x="4983479" y="2971800"/>
+            <a:off x="4983479" y="2788920"/>
             <a:ext cx="1371600" cy="38100"/>
           </a:xfrm>
           <a:prstGeom prst="rect">
@@ -8853,7 +8853,7 @@
         </p:nvSpPr>
         <p:spPr>
           <a:xfrm>
-            <a:off x="5056631" y="3081528"/>
+            <a:off x="5056631" y="2862072"/>
             <a:ext cx="1234440" cy="201168"/>
           </a:xfrm>
           <a:prstGeom prst="rect">
@@ -8889,7 +8889,7 @@
         </p:nvSpPr>
         <p:spPr>
           <a:xfrm>
-            <a:off x="5056631" y="3319272"/>
+            <a:off x="5056631" y="3081528"/>
             <a:ext cx="1234440" cy="274320"/>
           </a:xfrm>
           <a:prstGeom prst="rect">
@@ -8925,8 +8925,8 @@
         </p:nvSpPr>
         <p:spPr>
           <a:xfrm>
-            <a:off x="6492240" y="2971800"/>
-            <a:ext cx="1371600" cy="731520"/>
+            <a:off x="6492240" y="2788920"/>
+            <a:ext cx="1371600" cy="640080"/>
           </a:xfrm>
           <a:prstGeom prst="roundRect">
             <a:avLst/>
@@ -8968,7 +8968,7 @@
         </p:nvSpPr>
         <p:spPr>
           <a:xfrm>
-            <a:off x="6492240" y="2971800"/>
+            <a:off x="6492240" y="2788920"/>
             <a:ext cx="1371600" cy="38100"/>
           </a:xfrm>
           <a:prstGeom prst="rect">
@@ -9011,7 +9011,7 @@
         </p:nvSpPr>
         <p:spPr>
           <a:xfrm>
-            <a:off x="6565392" y="3081528"/>
+            <a:off x="6565392" y="2862072"/>
             <a:ext cx="1234440" cy="201168"/>
           </a:xfrm>
           <a:prstGeom prst="rect">
@@ -9047,7 +9047,7 @@
         </p:nvSpPr>
         <p:spPr>
           <a:xfrm>
-            <a:off x="6565392" y="3319272"/>
+            <a:off x="6565392" y="3081528"/>
             <a:ext cx="1234440" cy="274320"/>
           </a:xfrm>
           <a:prstGeom prst="rect">
@@ -9077,50 +9077,14 @@
       </p:sp>
       <p:sp>
         <p:nvSpPr>
-          <p:cNvPr id="64" name="TextBox 63"/>
-          <p:cNvSpPr txBox="1"/>
-          <p:nvPr/>
-        </p:nvSpPr>
-        <p:spPr>
-          <a:xfrm>
-            <a:off x="8001000" y="1143000"/>
-            <a:ext cx="3657600" cy="228600"/>
-          </a:xfrm>
-          <a:prstGeom prst="rect">
-            <a:avLst/>
-          </a:prstGeom>
-          <a:noFill/>
-        </p:spPr>
-        <p:txBody>
-          <a:bodyPr wrap="square">
-            <a:spAutoFit/>
-          </a:bodyPr>
-          <a:lstStyle/>
-          <a:p>
-            <a:pPr algn="l">
-              <a:defRPr sz="900" b="1">
-                <a:solidFill>
-                  <a:srgbClr val="5A5E66"/>
-                </a:solidFill>
-                <a:latin typeface="Calibri"/>
-              </a:defRPr>
-            </a:pPr>
-            <a:r>
-              <a:t>COMPETITIVE (12 CATEGORIES, 40+ RIVALS)</a:t>
-            </a:r>
-          </a:p>
-        </p:txBody>
-      </p:sp>
-      <p:sp>
-        <p:nvSpPr>
-          <p:cNvPr id="65" name="Rounded Rectangle 64"/>
+          <p:cNvPr id="64" name="Rounded Rectangle 63"/>
           <p:cNvSpPr/>
           <p:nvPr/>
         </p:nvSpPr>
         <p:spPr>
           <a:xfrm>
-            <a:off x="8001000" y="1463040"/>
-            <a:ext cx="3749039" cy="292608"/>
+            <a:off x="457200" y="3566160"/>
+            <a:ext cx="1371600" cy="640080"/>
           </a:xfrm>
           <a:prstGeom prst="roundRect">
             <a:avLst/>
@@ -9156,56 +9120,20 @@
       </p:sp>
       <p:sp>
         <p:nvSpPr>
-          <p:cNvPr id="66" name="TextBox 65"/>
-          <p:cNvSpPr txBox="1"/>
-          <p:nvPr/>
-        </p:nvSpPr>
-        <p:spPr>
-          <a:xfrm>
-            <a:off x="8119872" y="1499616"/>
-            <a:ext cx="3520440" cy="201168"/>
-          </a:xfrm>
-          <a:prstGeom prst="rect">
-            <a:avLst/>
-          </a:prstGeom>
-          <a:noFill/>
-        </p:spPr>
-        <p:txBody>
-          <a:bodyPr wrap="square">
-            <a:spAutoFit/>
-          </a:bodyPr>
-          <a:lstStyle/>
-          <a:p>
-            <a:pPr algn="l">
-              <a:defRPr sz="900" b="0">
-                <a:solidFill>
-                  <a:srgbClr val="C4C9D4"/>
-                </a:solidFill>
-                <a:latin typeface="Calibri"/>
-              </a:defRPr>
-            </a:pPr>
-            <a:r>
-              <a:t>CDN -- Akamai, CloudFront, Fastly</a:t>
-            </a:r>
-          </a:p>
-        </p:txBody>
-      </p:sp>
-      <p:sp>
-        <p:nvSpPr>
-          <p:cNvPr id="67" name="Rounded Rectangle 66"/>
+          <p:cNvPr id="65" name="Rectangle 64"/>
           <p:cNvSpPr/>
           <p:nvPr/>
         </p:nvSpPr>
         <p:spPr>
           <a:xfrm>
-            <a:off x="8001000" y="1847088"/>
-            <a:ext cx="3749039" cy="292608"/>
-          </a:xfrm>
-          <a:prstGeom prst="roundRect">
-            <a:avLst/>
-          </a:prstGeom>
-          <a:solidFill>
-            <a:srgbClr val="161718"/>
+            <a:off x="457200" y="3566160"/>
+            <a:ext cx="1371600" cy="38100"/>
+          </a:xfrm>
+          <a:prstGeom prst="rect">
+            <a:avLst/>
+          </a:prstGeom>
+          <a:solidFill>
+            <a:srgbClr val="34D399"/>
           </a:solidFill>
           <a:ln>
             <a:noFill/>
@@ -9235,14 +9163,14 @@
       </p:sp>
       <p:sp>
         <p:nvSpPr>
-          <p:cNvPr id="68" name="TextBox 67"/>
+          <p:cNvPr id="66" name="TextBox 65"/>
           <p:cNvSpPr txBox="1"/>
           <p:nvPr/>
         </p:nvSpPr>
         <p:spPr>
           <a:xfrm>
-            <a:off x="8119872" y="1883664"/>
-            <a:ext cx="3520440" cy="201168"/>
+            <a:off x="530352" y="3639312"/>
+            <a:ext cx="1234440" cy="201168"/>
           </a:xfrm>
           <a:prstGeom prst="rect">
             <a:avLst/>
@@ -9256,15 +9184,87 @@
           <a:lstStyle/>
           <a:p>
             <a:pPr algn="l">
-              <a:defRPr sz="900" b="0">
-                <a:solidFill>
-                  <a:srgbClr val="C4C9D4"/>
+              <a:defRPr sz="1000" b="1">
+                <a:solidFill>
+                  <a:srgbClr val="34D399"/>
                 </a:solidFill>
                 <a:latin typeface="Calibri"/>
               </a:defRPr>
             </a:pPr>
             <a:r>
-              <a:t>WAF -- Imperva, AWS WAF, F5</a:t>
+              <a:t>Email Approval</a:t>
+            </a:r>
+          </a:p>
+        </p:txBody>
+      </p:sp>
+      <p:sp>
+        <p:nvSpPr>
+          <p:cNvPr id="67" name="TextBox 66"/>
+          <p:cNvSpPr txBox="1"/>
+          <p:nvPr/>
+        </p:nvSpPr>
+        <p:spPr>
+          <a:xfrm>
+            <a:off x="530352" y="3858768"/>
+            <a:ext cx="1234440" cy="274320"/>
+          </a:xfrm>
+          <a:prstGeom prst="rect">
+            <a:avLst/>
+          </a:prstGeom>
+          <a:noFill/>
+        </p:spPr>
+        <p:txBody>
+          <a:bodyPr wrap="square">
+            <a:spAutoFit/>
+          </a:bodyPr>
+          <a:lstStyle/>
+          <a:p>
+            <a:pPr algn="l">
+              <a:defRPr sz="800" b="0">
+                <a:solidFill>
+                  <a:srgbClr val="8A8F98"/>
+                </a:solidFill>
+                <a:latin typeface="Calibri"/>
+              </a:defRPr>
+            </a:pPr>
+            <a:r>
+              <a:t>Review &amp; gate</a:t>
+            </a:r>
+          </a:p>
+        </p:txBody>
+      </p:sp>
+      <p:sp>
+        <p:nvSpPr>
+          <p:cNvPr id="68" name="TextBox 67"/>
+          <p:cNvSpPr txBox="1"/>
+          <p:nvPr/>
+        </p:nvSpPr>
+        <p:spPr>
+          <a:xfrm>
+            <a:off x="8001000" y="1143000"/>
+            <a:ext cx="3657600" cy="228600"/>
+          </a:xfrm>
+          <a:prstGeom prst="rect">
+            <a:avLst/>
+          </a:prstGeom>
+          <a:noFill/>
+        </p:spPr>
+        <p:txBody>
+          <a:bodyPr wrap="square">
+            <a:spAutoFit/>
+          </a:bodyPr>
+          <a:lstStyle/>
+          <a:p>
+            <a:pPr algn="l">
+              <a:defRPr sz="900" b="1">
+                <a:solidFill>
+                  <a:srgbClr val="5A5E66"/>
+                </a:solidFill>
+                <a:latin typeface="Calibri"/>
+              </a:defRPr>
+            </a:pPr>
+            <a:r>
+              <a:t>COMPETITIVE (12 CATEGORIES, 40+ RIVALS)</a:t>
             </a:r>
           </a:p>
         </p:txBody>
@@ -9277,7 +9277,7 @@
         </p:nvSpPr>
         <p:spPr>
           <a:xfrm>
-            <a:off x="8001000" y="2231136"/>
+            <a:off x="8001000" y="1463040"/>
             <a:ext cx="3749039" cy="292608"/>
           </a:xfrm>
           <a:prstGeom prst="roundRect">
@@ -9320,7 +9320,7 @@
         </p:nvSpPr>
         <p:spPr>
           <a:xfrm>
-            <a:off x="8119872" y="2267712"/>
+            <a:off x="8119872" y="1499616"/>
             <a:ext cx="3520440" cy="201168"/>
           </a:xfrm>
           <a:prstGeom prst="rect">
@@ -9343,7 +9343,7 @@
               </a:defRPr>
             </a:pPr>
             <a:r>
-              <a:t>DDoS -- Prolexic, AWS Shield</a:t>
+              <a:t>CDN -- Akamai, CloudFront, Fastly</a:t>
             </a:r>
           </a:p>
         </p:txBody>
@@ -9356,7 +9356,7 @@
         </p:nvSpPr>
         <p:spPr>
           <a:xfrm>
-            <a:off x="8001000" y="2615184"/>
+            <a:off x="8001000" y="1847088"/>
             <a:ext cx="3749039" cy="292608"/>
           </a:xfrm>
           <a:prstGeom prst="roundRect">
@@ -9399,7 +9399,7 @@
         </p:nvSpPr>
         <p:spPr>
           <a:xfrm>
-            <a:off x="8119872" y="2651760"/>
+            <a:off x="8119872" y="1883664"/>
             <a:ext cx="3520440" cy="201168"/>
           </a:xfrm>
           <a:prstGeom prst="rect">
@@ -9422,7 +9422,7 @@
               </a:defRPr>
             </a:pPr>
             <a:r>
-              <a:t>Zero Trust -- Zscaler, Palo Alto</a:t>
+              <a:t>WAF -- Imperva, AWS WAF, F5</a:t>
             </a:r>
           </a:p>
         </p:txBody>
@@ -9435,7 +9435,7 @@
         </p:nvSpPr>
         <p:spPr>
           <a:xfrm>
-            <a:off x="8001000" y="2999232"/>
+            <a:off x="8001000" y="2231136"/>
             <a:ext cx="3749039" cy="292608"/>
           </a:xfrm>
           <a:prstGeom prst="roundRect">
@@ -9478,7 +9478,7 @@
         </p:nvSpPr>
         <p:spPr>
           <a:xfrm>
-            <a:off x="8119872" y="3035808"/>
+            <a:off x="8119872" y="2267712"/>
             <a:ext cx="3520440" cy="201168"/>
           </a:xfrm>
           <a:prstGeom prst="rect">
@@ -9501,7 +9501,7 @@
               </a:defRPr>
             </a:pPr>
             <a:r>
-              <a:t>Edge Compute -- Lambda@Edge, Vercel</a:t>
+              <a:t>DDoS -- Prolexic, AWS Shield</a:t>
             </a:r>
           </a:p>
         </p:txBody>
@@ -9514,7 +9514,7 @@
         </p:nvSpPr>
         <p:spPr>
           <a:xfrm>
-            <a:off x="8001000" y="3383280"/>
+            <a:off x="8001000" y="2615184"/>
             <a:ext cx="3749039" cy="292608"/>
           </a:xfrm>
           <a:prstGeom prst="roundRect">
@@ -9557,7 +9557,7 @@
         </p:nvSpPr>
         <p:spPr>
           <a:xfrm>
-            <a:off x="8119872" y="3419856"/>
+            <a:off x="8119872" y="2651760"/>
             <a:ext cx="3520440" cy="201168"/>
           </a:xfrm>
           <a:prstGeom prst="rect">
@@ -9580,57 +9580,21 @@
               </a:defRPr>
             </a:pPr>
             <a:r>
-              <a:t>DNS -- Route 53, NS1, Google</a:t>
-            </a:r>
-          </a:p>
-        </p:txBody>
-      </p:sp>
-      <p:sp>
-        <p:nvSpPr>
-          <p:cNvPr id="77" name="TextBox 76"/>
-          <p:cNvSpPr txBox="1"/>
-          <p:nvPr/>
-        </p:nvSpPr>
-        <p:spPr>
-          <a:xfrm>
-            <a:off x="457200" y="3977639"/>
-            <a:ext cx="4572000" cy="228600"/>
-          </a:xfrm>
-          <a:prstGeom prst="rect">
-            <a:avLst/>
-          </a:prstGeom>
-          <a:noFill/>
-        </p:spPr>
-        <p:txBody>
-          <a:bodyPr wrap="square">
-            <a:spAutoFit/>
-          </a:bodyPr>
-          <a:lstStyle/>
-          <a:p>
-            <a:pPr algn="l">
-              <a:defRPr sz="900" b="1">
-                <a:solidFill>
-                  <a:srgbClr val="5A5E66"/>
-                </a:solidFill>
-                <a:latin typeface="Calibri"/>
-              </a:defRPr>
-            </a:pPr>
-            <a:r>
-              <a:t>THREAT INTELLIGENCE</a:t>
-            </a:r>
-          </a:p>
-        </p:txBody>
-      </p:sp>
-      <p:sp>
-        <p:nvSpPr>
-          <p:cNvPr id="78" name="Rounded Rectangle 77"/>
+              <a:t>Zero Trust -- Zscaler, Palo Alto</a:t>
+            </a:r>
+          </a:p>
+        </p:txBody>
+      </p:sp>
+      <p:sp>
+        <p:nvSpPr>
+          <p:cNvPr id="77" name="Rounded Rectangle 76"/>
           <p:cNvSpPr/>
           <p:nvPr/>
         </p:nvSpPr>
         <p:spPr>
           <a:xfrm>
-            <a:off x="457200" y="4251960"/>
-            <a:ext cx="2194560" cy="594360"/>
+            <a:off x="8001000" y="2999232"/>
+            <a:ext cx="3749039" cy="292608"/>
           </a:xfrm>
           <a:prstGeom prst="roundRect">
             <a:avLst/>
@@ -9666,20 +9630,56 @@
       </p:sp>
       <p:sp>
         <p:nvSpPr>
-          <p:cNvPr id="79" name="Rectangle 78"/>
+          <p:cNvPr id="78" name="TextBox 77"/>
+          <p:cNvSpPr txBox="1"/>
+          <p:nvPr/>
+        </p:nvSpPr>
+        <p:spPr>
+          <a:xfrm>
+            <a:off x="8119872" y="3035808"/>
+            <a:ext cx="3520440" cy="201168"/>
+          </a:xfrm>
+          <a:prstGeom prst="rect">
+            <a:avLst/>
+          </a:prstGeom>
+          <a:noFill/>
+        </p:spPr>
+        <p:txBody>
+          <a:bodyPr wrap="square">
+            <a:spAutoFit/>
+          </a:bodyPr>
+          <a:lstStyle/>
+          <a:p>
+            <a:pPr algn="l">
+              <a:defRPr sz="900" b="0">
+                <a:solidFill>
+                  <a:srgbClr val="C4C9D4"/>
+                </a:solidFill>
+                <a:latin typeface="Calibri"/>
+              </a:defRPr>
+            </a:pPr>
+            <a:r>
+              <a:t>Edge Compute -- Lambda@Edge, Vercel</a:t>
+            </a:r>
+          </a:p>
+        </p:txBody>
+      </p:sp>
+      <p:sp>
+        <p:nvSpPr>
+          <p:cNvPr id="79" name="Rounded Rectangle 78"/>
           <p:cNvSpPr/>
           <p:nvPr/>
         </p:nvSpPr>
         <p:spPr>
           <a:xfrm>
-            <a:off x="457200" y="4251960"/>
-            <a:ext cx="38100" cy="594360"/>
-          </a:xfrm>
-          <a:prstGeom prst="rect">
-            <a:avLst/>
-          </a:prstGeom>
-          <a:solidFill>
-            <a:srgbClr val="F87171"/>
+            <a:off x="8001000" y="3383280"/>
+            <a:ext cx="3749039" cy="292608"/>
+          </a:xfrm>
+          <a:prstGeom prst="roundRect">
+            <a:avLst/>
+          </a:prstGeom>
+          <a:solidFill>
+            <a:srgbClr val="161718"/>
           </a:solidFill>
           <a:ln>
             <a:noFill/>
@@ -9715,8 +9715,8 @@
         </p:nvSpPr>
         <p:spPr>
           <a:xfrm>
-            <a:off x="594360" y="4297680"/>
-            <a:ext cx="1920240" cy="182880"/>
+            <a:off x="8119872" y="3419856"/>
+            <a:ext cx="3520440" cy="201168"/>
           </a:xfrm>
           <a:prstGeom prst="rect">
             <a:avLst/>
@@ -9730,15 +9730,15 @@
           <a:lstStyle/>
           <a:p>
             <a:pPr algn="l">
-              <a:defRPr sz="1000" b="1">
-                <a:solidFill>
-                  <a:srgbClr val="F87171"/>
+              <a:defRPr sz="900" b="0">
+                <a:solidFill>
+                  <a:srgbClr val="C4C9D4"/>
                 </a:solidFill>
                 <a:latin typeface="Calibri"/>
               </a:defRPr>
             </a:pPr>
             <a:r>
-              <a:t>26 RSS Feeds</a:t>
+              <a:t>DNS -- Route 53, NS1, Google</a:t>
             </a:r>
           </a:p>
         </p:txBody>
@@ -9751,8 +9751,8 @@
         </p:nvSpPr>
         <p:spPr>
           <a:xfrm>
-            <a:off x="594360" y="4526280"/>
-            <a:ext cx="1920240" cy="182880"/>
+            <a:off x="457200" y="3977639"/>
+            <a:ext cx="4572000" cy="228600"/>
           </a:xfrm>
           <a:prstGeom prst="rect">
             <a:avLst/>
@@ -9766,15 +9766,15 @@
           <a:lstStyle/>
           <a:p>
             <a:pPr algn="l">
-              <a:defRPr sz="800" b="0">
-                <a:solidFill>
-                  <a:srgbClr val="8A8F98"/>
+              <a:defRPr sz="900" b="1">
+                <a:solidFill>
+                  <a:srgbClr val="5A5E66"/>
                 </a:solidFill>
                 <a:latin typeface="Calibri"/>
               </a:defRPr>
             </a:pPr>
             <a:r>
-              <a:t>Real-time incidents</a:t>
+              <a:t>THREAT INTELLIGENCE</a:t>
             </a:r>
           </a:p>
         </p:txBody>
@@ -9787,7 +9787,7 @@
         </p:nvSpPr>
         <p:spPr>
           <a:xfrm>
-            <a:off x="2788920" y="4251960"/>
+            <a:off x="457200" y="4251960"/>
             <a:ext cx="2194560" cy="594360"/>
           </a:xfrm>
           <a:prstGeom prst="roundRect">
@@ -9830,14 +9830,14 @@
         </p:nvSpPr>
         <p:spPr>
           <a:xfrm>
-            <a:off x="2788920" y="4251960"/>
+            <a:off x="457200" y="4251960"/>
             <a:ext cx="38100" cy="594360"/>
           </a:xfrm>
           <a:prstGeom prst="rect">
             <a:avLst/>
           </a:prstGeom>
           <a:solidFill>
-            <a:srgbClr val="FBBF24"/>
+            <a:srgbClr val="F87171"/>
           </a:solidFill>
           <a:ln>
             <a:noFill/>
@@ -9873,7 +9873,7 @@
         </p:nvSpPr>
         <p:spPr>
           <a:xfrm>
-            <a:off x="2926080" y="4297680"/>
+            <a:off x="594360" y="4297680"/>
             <a:ext cx="1920240" cy="182880"/>
           </a:xfrm>
           <a:prstGeom prst="rect">
@@ -9890,13 +9890,13 @@
             <a:pPr algn="l">
               <a:defRPr sz="1000" b="1">
                 <a:solidFill>
-                  <a:srgbClr val="FBBF24"/>
+                  <a:srgbClr val="F87171"/>
                 </a:solidFill>
                 <a:latin typeface="Calibri"/>
               </a:defRPr>
             </a:pPr>
             <a:r>
-              <a:t>GDELT + 5 News APIs</a:t>
+              <a:t>26 RSS Feeds</a:t>
             </a:r>
           </a:p>
         </p:txBody>
@@ -9909,7 +9909,7 @@
         </p:nvSpPr>
         <p:spPr>
           <a:xfrm>
-            <a:off x="2926080" y="4526280"/>
+            <a:off x="594360" y="4526280"/>
             <a:ext cx="1920240" cy="182880"/>
           </a:xfrm>
           <a:prstGeom prst="rect">
@@ -9932,7 +9932,7 @@
               </a:defRPr>
             </a:pPr>
             <a:r>
-              <a:t>Google, Bing, NewsAPI, GNews, MediaStack</a:t>
+              <a:t>Real-time incidents</a:t>
             </a:r>
           </a:p>
         </p:txBody>
@@ -9945,7 +9945,7 @@
         </p:nvSpPr>
         <p:spPr>
           <a:xfrm>
-            <a:off x="5120640" y="4251960"/>
+            <a:off x="2788920" y="4251960"/>
             <a:ext cx="2194560" cy="594360"/>
           </a:xfrm>
           <a:prstGeom prst="roundRect">
@@ -9988,14 +9988,14 @@
         </p:nvSpPr>
         <p:spPr>
           <a:xfrm>
-            <a:off x="5120640" y="4251960"/>
+            <a:off x="2788920" y="4251960"/>
             <a:ext cx="38100" cy="594360"/>
           </a:xfrm>
           <a:prstGeom prst="rect">
             <a:avLst/>
           </a:prstGeom>
           <a:solidFill>
-            <a:srgbClr val="60A5FA"/>
+            <a:srgbClr val="FBBF24"/>
           </a:solidFill>
           <a:ln>
             <a:noFill/>
@@ -10031,7 +10031,7 @@
         </p:nvSpPr>
         <p:spPr>
           <a:xfrm>
-            <a:off x="5257800" y="4297680"/>
+            <a:off x="2926080" y="4297680"/>
             <a:ext cx="1920240" cy="182880"/>
           </a:xfrm>
           <a:prstGeom prst="rect">
@@ -10048,13 +10048,13 @@
             <a:pPr algn="l">
               <a:defRPr sz="1000" b="1">
                 <a:solidFill>
-                  <a:srgbClr val="60A5FA"/>
+                  <a:srgbClr val="FBBF24"/>
                 </a:solidFill>
                 <a:latin typeface="Calibri"/>
               </a:defRPr>
             </a:pPr>
             <a:r>
-              <a:t>Auto-Match</a:t>
+              <a:t>GDELT + 5 News APIs</a:t>
             </a:r>
           </a:p>
         </p:txBody>
@@ -10067,7 +10067,7 @@
         </p:nvSpPr>
         <p:spPr>
           <a:xfrm>
-            <a:off x="5257800" y="4526280"/>
+            <a:off x="2926080" y="4526280"/>
             <a:ext cx="1920240" cy="182880"/>
           </a:xfrm>
           <a:prstGeom prst="rect">
@@ -10090,7 +10090,7 @@
               </a:defRPr>
             </a:pPr>
             <a:r>
-              <a:t>By industry &amp; country</a:t>
+              <a:t>Google, Bing, NewsAPI, GNews, MediaStack</a:t>
             </a:r>
           </a:p>
         </p:txBody>
@@ -10103,7 +10103,7 @@
         </p:nvSpPr>
         <p:spPr>
           <a:xfrm>
-            <a:off x="7452359" y="4251960"/>
+            <a:off x="5120640" y="4251960"/>
             <a:ext cx="2194560" cy="594360"/>
           </a:xfrm>
           <a:prstGeom prst="roundRect">
@@ -10146,14 +10146,14 @@
         </p:nvSpPr>
         <p:spPr>
           <a:xfrm>
-            <a:off x="7452359" y="4251960"/>
+            <a:off x="5120640" y="4251960"/>
             <a:ext cx="38100" cy="594360"/>
           </a:xfrm>
           <a:prstGeom prst="rect">
             <a:avLst/>
           </a:prstGeom>
           <a:solidFill>
-            <a:srgbClr val="34D399"/>
+            <a:srgbClr val="60A5FA"/>
           </a:solidFill>
           <a:ln>
             <a:noFill/>
@@ -10189,7 +10189,7 @@
         </p:nvSpPr>
         <p:spPr>
           <a:xfrm>
-            <a:off x="7589519" y="4297680"/>
+            <a:off x="5257800" y="4297680"/>
             <a:ext cx="1920240" cy="182880"/>
           </a:xfrm>
           <a:prstGeom prst="rect">
@@ -10206,13 +10206,13 @@
             <a:pPr algn="l">
               <a:defRPr sz="1000" b="1">
                 <a:solidFill>
-                  <a:srgbClr val="34D399"/>
+                  <a:srgbClr val="60A5FA"/>
                 </a:solidFill>
                 <a:latin typeface="Calibri"/>
               </a:defRPr>
             </a:pPr>
             <a:r>
-              <a:t>Trigger Emails</a:t>
+              <a:t>Auto-Match</a:t>
             </a:r>
           </a:p>
         </p:txBody>
@@ -10225,7 +10225,7 @@
         </p:nvSpPr>
         <p:spPr>
           <a:xfrm>
-            <a:off x="7589519" y="4526280"/>
+            <a:off x="5257800" y="4526280"/>
             <a:ext cx="1920240" cy="182880"/>
           </a:xfrm>
           <a:prstGeom prst="rect">
@@ -10248,7 +10248,7 @@
               </a:defRPr>
             </a:pPr>
             <a:r>
-              <a:t>Incident outreach</a:t>
+              <a:t>By industry &amp; country</a:t>
             </a:r>
           </a:p>
         </p:txBody>
@@ -10261,7 +10261,7 @@
         </p:nvSpPr>
         <p:spPr>
           <a:xfrm>
-            <a:off x="9784080" y="4251960"/>
+            <a:off x="7452359" y="4251960"/>
             <a:ext cx="2194560" cy="594360"/>
           </a:xfrm>
           <a:prstGeom prst="roundRect">
@@ -10304,14 +10304,14 @@
         </p:nvSpPr>
         <p:spPr>
           <a:xfrm>
-            <a:off x="9784080" y="4251960"/>
+            <a:off x="7452359" y="4251960"/>
             <a:ext cx="38100" cy="594360"/>
           </a:xfrm>
           <a:prstGeom prst="rect">
             <a:avLst/>
           </a:prstGeom>
           <a:solidFill>
-            <a:srgbClr val="A78BFA"/>
+            <a:srgbClr val="34D399"/>
           </a:solidFill>
           <a:ln>
             <a:noFill/>
@@ -10347,7 +10347,7 @@
         </p:nvSpPr>
         <p:spPr>
           <a:xfrm>
-            <a:off x="9921240" y="4297680"/>
+            <a:off x="7589519" y="4297680"/>
             <a:ext cx="1920240" cy="182880"/>
           </a:xfrm>
           <a:prstGeom prst="rect">
@@ -10364,13 +10364,13 @@
             <a:pPr algn="l">
               <a:defRPr sz="1000" b="1">
                 <a:solidFill>
-                  <a:srgbClr val="A78BFA"/>
+                  <a:srgbClr val="34D399"/>
                 </a:solidFill>
                 <a:latin typeface="Calibri"/>
               </a:defRPr>
             </a:pPr>
             <a:r>
-              <a:t>Nightly Cron</a:t>
+              <a:t>Trigger Emails</a:t>
             </a:r>
           </a:p>
         </p:txBody>
@@ -10383,7 +10383,7 @@
         </p:nvSpPr>
         <p:spPr>
           <a:xfrm>
-            <a:off x="9921240" y="4526280"/>
+            <a:off x="7589519" y="4526280"/>
             <a:ext cx="1920240" cy="182880"/>
           </a:xfrm>
           <a:prstGeom prst="rect">
@@ -10406,57 +10406,21 @@
               </a:defRPr>
             </a:pPr>
             <a:r>
-              <a:t>Daily scan + alerts</a:t>
-            </a:r>
-          </a:p>
-        </p:txBody>
-      </p:sp>
-      <p:sp>
-        <p:nvSpPr>
-          <p:cNvPr id="98" name="TextBox 97"/>
-          <p:cNvSpPr txBox="1"/>
-          <p:nvPr/>
-        </p:nvSpPr>
-        <p:spPr>
-          <a:xfrm>
-            <a:off x="457200" y="5074920"/>
-            <a:ext cx="4572000" cy="228600"/>
-          </a:xfrm>
-          <a:prstGeom prst="rect">
-            <a:avLst/>
-          </a:prstGeom>
-          <a:noFill/>
-        </p:spPr>
-        <p:txBody>
-          <a:bodyPr wrap="square">
-            <a:spAutoFit/>
-          </a:bodyPr>
-          <a:lstStyle/>
-          <a:p>
-            <a:pPr algn="l">
-              <a:defRPr sz="900" b="1">
-                <a:solidFill>
-                  <a:srgbClr val="5A5E66"/>
-                </a:solidFill>
-                <a:latin typeface="Calibri"/>
-              </a:defRPr>
-            </a:pPr>
-            <a:r>
-              <a:t>SECURITY &amp; INTEGRATIONS</a:t>
-            </a:r>
-          </a:p>
-        </p:txBody>
-      </p:sp>
-      <p:sp>
-        <p:nvSpPr>
-          <p:cNvPr id="99" name="Rounded Rectangle 98"/>
+              <a:t>Incident outreach</a:t>
+            </a:r>
+          </a:p>
+        </p:txBody>
+      </p:sp>
+      <p:sp>
+        <p:nvSpPr>
+          <p:cNvPr id="98" name="Rounded Rectangle 97"/>
           <p:cNvSpPr/>
           <p:nvPr/>
         </p:nvSpPr>
         <p:spPr>
           <a:xfrm>
-            <a:off x="457200" y="5349240"/>
-            <a:ext cx="1188720" cy="365760"/>
+            <a:off x="9784080" y="4251960"/>
+            <a:ext cx="2194560" cy="594360"/>
           </a:xfrm>
           <a:prstGeom prst="roundRect">
             <a:avLst/>
@@ -10492,20 +10456,20 @@
       </p:sp>
       <p:sp>
         <p:nvSpPr>
-          <p:cNvPr id="100" name="Rectangle 99"/>
+          <p:cNvPr id="99" name="Rectangle 98"/>
           <p:cNvSpPr/>
           <p:nvPr/>
         </p:nvSpPr>
         <p:spPr>
           <a:xfrm>
-            <a:off x="457200" y="5349240"/>
-            <a:ext cx="1188720" cy="38100"/>
-          </a:xfrm>
-          <a:prstGeom prst="rect">
-            <a:avLst/>
-          </a:prstGeom>
-          <a:solidFill>
-            <a:srgbClr val="34D399"/>
+            <a:off x="9784080" y="4251960"/>
+            <a:ext cx="38100" cy="594360"/>
+          </a:xfrm>
+          <a:prstGeom prst="rect">
+            <a:avLst/>
+          </a:prstGeom>
+          <a:solidFill>
+            <a:srgbClr val="A78BFA"/>
           </a:solidFill>
           <a:ln>
             <a:noFill/>
@@ -10535,14 +10499,14 @@
       </p:sp>
       <p:sp>
         <p:nvSpPr>
-          <p:cNvPr id="101" name="TextBox 100"/>
+          <p:cNvPr id="100" name="TextBox 99"/>
           <p:cNvSpPr txBox="1"/>
           <p:nvPr/>
         </p:nvSpPr>
         <p:spPr>
           <a:xfrm>
-            <a:off x="530352" y="5422392"/>
-            <a:ext cx="1097280" cy="228600"/>
+            <a:off x="9921240" y="4297680"/>
+            <a:ext cx="1920240" cy="182880"/>
           </a:xfrm>
           <a:prstGeom prst="rect">
             <a:avLst/>
@@ -10556,28 +10520,100 @@
           <a:lstStyle/>
           <a:p>
             <a:pPr algn="l">
-              <a:defRPr sz="800" b="1">
-                <a:solidFill>
-                  <a:srgbClr val="34D399"/>
+              <a:defRPr sz="1000" b="1">
+                <a:solidFill>
+                  <a:srgbClr val="A78BFA"/>
                 </a:solidFill>
                 <a:latin typeface="Calibri"/>
               </a:defRPr>
             </a:pPr>
             <a:r>
-              <a:t>Zero Trust Auth</a:t>
-            </a:r>
-          </a:p>
-        </p:txBody>
-      </p:sp>
-      <p:sp>
-        <p:nvSpPr>
-          <p:cNvPr id="102" name="Rounded Rectangle 101"/>
+              <a:t>Nightly Cron</a:t>
+            </a:r>
+          </a:p>
+        </p:txBody>
+      </p:sp>
+      <p:sp>
+        <p:nvSpPr>
+          <p:cNvPr id="101" name="TextBox 100"/>
+          <p:cNvSpPr txBox="1"/>
+          <p:nvPr/>
+        </p:nvSpPr>
+        <p:spPr>
+          <a:xfrm>
+            <a:off x="9921240" y="4526280"/>
+            <a:ext cx="1920240" cy="182880"/>
+          </a:xfrm>
+          <a:prstGeom prst="rect">
+            <a:avLst/>
+          </a:prstGeom>
+          <a:noFill/>
+        </p:spPr>
+        <p:txBody>
+          <a:bodyPr wrap="square">
+            <a:spAutoFit/>
+          </a:bodyPr>
+          <a:lstStyle/>
+          <a:p>
+            <a:pPr algn="l">
+              <a:defRPr sz="800" b="0">
+                <a:solidFill>
+                  <a:srgbClr val="8A8F98"/>
+                </a:solidFill>
+                <a:latin typeface="Calibri"/>
+              </a:defRPr>
+            </a:pPr>
+            <a:r>
+              <a:t>Daily scan + alerts</a:t>
+            </a:r>
+          </a:p>
+        </p:txBody>
+      </p:sp>
+      <p:sp>
+        <p:nvSpPr>
+          <p:cNvPr id="102" name="TextBox 101"/>
+          <p:cNvSpPr txBox="1"/>
+          <p:nvPr/>
+        </p:nvSpPr>
+        <p:spPr>
+          <a:xfrm>
+            <a:off x="457200" y="5074920"/>
+            <a:ext cx="4572000" cy="228600"/>
+          </a:xfrm>
+          <a:prstGeom prst="rect">
+            <a:avLst/>
+          </a:prstGeom>
+          <a:noFill/>
+        </p:spPr>
+        <p:txBody>
+          <a:bodyPr wrap="square">
+            <a:spAutoFit/>
+          </a:bodyPr>
+          <a:lstStyle/>
+          <a:p>
+            <a:pPr algn="l">
+              <a:defRPr sz="900" b="1">
+                <a:solidFill>
+                  <a:srgbClr val="5A5E66"/>
+                </a:solidFill>
+                <a:latin typeface="Calibri"/>
+              </a:defRPr>
+            </a:pPr>
+            <a:r>
+              <a:t>SECURITY &amp; INTEGRATIONS</a:t>
+            </a:r>
+          </a:p>
+        </p:txBody>
+      </p:sp>
+      <p:sp>
+        <p:nvSpPr>
+          <p:cNvPr id="103" name="Rounded Rectangle 102"/>
           <p:cNvSpPr/>
           <p:nvPr/>
         </p:nvSpPr>
         <p:spPr>
           <a:xfrm>
-            <a:off x="1737360" y="5349240"/>
+            <a:off x="457200" y="5349240"/>
             <a:ext cx="1188720" cy="365760"/>
           </a:xfrm>
           <a:prstGeom prst="roundRect">
@@ -10614,20 +10650,20 @@
       </p:sp>
       <p:sp>
         <p:nvSpPr>
-          <p:cNvPr id="103" name="Rectangle 102"/>
+          <p:cNvPr id="104" name="Rectangle 103"/>
           <p:cNvSpPr/>
           <p:nvPr/>
         </p:nvSpPr>
         <p:spPr>
           <a:xfrm>
-            <a:off x="1737360" y="5349240"/>
+            <a:off x="457200" y="5349240"/>
             <a:ext cx="1188720" cy="38100"/>
           </a:xfrm>
           <a:prstGeom prst="rect">
             <a:avLst/>
           </a:prstGeom>
           <a:solidFill>
-            <a:srgbClr val="60A5FA"/>
+            <a:srgbClr val="34D399"/>
           </a:solidFill>
           <a:ln>
             <a:noFill/>
@@ -10657,13 +10693,13 @@
       </p:sp>
       <p:sp>
         <p:nvSpPr>
-          <p:cNvPr id="104" name="TextBox 103"/>
+          <p:cNvPr id="105" name="TextBox 104"/>
           <p:cNvSpPr txBox="1"/>
           <p:nvPr/>
         </p:nvSpPr>
         <p:spPr>
           <a:xfrm>
-            <a:off x="1810512" y="5422392"/>
+            <a:off x="530352" y="5422392"/>
             <a:ext cx="1097280" cy="228600"/>
           </a:xfrm>
           <a:prstGeom prst="rect">
@@ -10680,26 +10716,26 @@
             <a:pPr algn="l">
               <a:defRPr sz="800" b="1">
                 <a:solidFill>
-                  <a:srgbClr val="60A5FA"/>
+                  <a:srgbClr val="34D399"/>
                 </a:solidFill>
                 <a:latin typeface="Calibri"/>
               </a:defRPr>
             </a:pPr>
             <a:r>
-              <a:t>AES-256-GCM</a:t>
-            </a:r>
-          </a:p>
-        </p:txBody>
-      </p:sp>
-      <p:sp>
-        <p:nvSpPr>
-          <p:cNvPr id="105" name="Rounded Rectangle 104"/>
+              <a:t>Zero Trust Auth</a:t>
+            </a:r>
+          </a:p>
+        </p:txBody>
+      </p:sp>
+      <p:sp>
+        <p:nvSpPr>
+          <p:cNvPr id="106" name="Rounded Rectangle 105"/>
           <p:cNvSpPr/>
           <p:nvPr/>
         </p:nvSpPr>
         <p:spPr>
           <a:xfrm>
-            <a:off x="3017520" y="5349240"/>
+            <a:off x="1737360" y="5349240"/>
             <a:ext cx="1188720" cy="365760"/>
           </a:xfrm>
           <a:prstGeom prst="roundRect">
@@ -10736,20 +10772,20 @@
       </p:sp>
       <p:sp>
         <p:nvSpPr>
-          <p:cNvPr id="106" name="Rectangle 105"/>
+          <p:cNvPr id="107" name="Rectangle 106"/>
           <p:cNvSpPr/>
           <p:nvPr/>
         </p:nvSpPr>
         <p:spPr>
           <a:xfrm>
-            <a:off x="3017520" y="5349240"/>
+            <a:off x="1737360" y="5349240"/>
             <a:ext cx="1188720" cy="38100"/>
           </a:xfrm>
           <a:prstGeom prst="rect">
             <a:avLst/>
           </a:prstGeom>
           <a:solidFill>
-            <a:srgbClr val="F87171"/>
+            <a:srgbClr val="60A5FA"/>
           </a:solidFill>
           <a:ln>
             <a:noFill/>
@@ -10779,13 +10815,13 @@
       </p:sp>
       <p:sp>
         <p:nvSpPr>
-          <p:cNvPr id="107" name="TextBox 106"/>
+          <p:cNvPr id="108" name="TextBox 107"/>
           <p:cNvSpPr txBox="1"/>
           <p:nvPr/>
         </p:nvSpPr>
         <p:spPr>
           <a:xfrm>
-            <a:off x="3090672" y="5422392"/>
+            <a:off x="1810512" y="5422392"/>
             <a:ext cx="1097280" cy="228600"/>
           </a:xfrm>
           <a:prstGeom prst="rect">
@@ -10802,26 +10838,26 @@
             <a:pPr algn="l">
               <a:defRPr sz="800" b="1">
                 <a:solidFill>
-                  <a:srgbClr val="F87171"/>
+                  <a:srgbClr val="60A5FA"/>
                 </a:solidFill>
                 <a:latin typeface="Calibri"/>
               </a:defRPr>
             </a:pPr>
             <a:r>
-              <a:t>SSRF Block</a:t>
-            </a:r>
-          </a:p>
-        </p:txBody>
-      </p:sp>
-      <p:sp>
-        <p:nvSpPr>
-          <p:cNvPr id="108" name="Rounded Rectangle 107"/>
+              <a:t>AES-256-GCM</a:t>
+            </a:r>
+          </a:p>
+        </p:txBody>
+      </p:sp>
+      <p:sp>
+        <p:nvSpPr>
+          <p:cNvPr id="109" name="Rounded Rectangle 108"/>
           <p:cNvSpPr/>
           <p:nvPr/>
         </p:nvSpPr>
         <p:spPr>
           <a:xfrm>
-            <a:off x="4297679" y="5349240"/>
+            <a:off x="3017520" y="5349240"/>
             <a:ext cx="1188720" cy="365760"/>
           </a:xfrm>
           <a:prstGeom prst="roundRect">
@@ -10858,20 +10894,20 @@
       </p:sp>
       <p:sp>
         <p:nvSpPr>
-          <p:cNvPr id="109" name="Rectangle 108"/>
+          <p:cNvPr id="110" name="Rectangle 109"/>
           <p:cNvSpPr/>
           <p:nvPr/>
         </p:nvSpPr>
         <p:spPr>
           <a:xfrm>
-            <a:off x="4297679" y="5349240"/>
+            <a:off x="3017520" y="5349240"/>
             <a:ext cx="1188720" cy="38100"/>
           </a:xfrm>
           <a:prstGeom prst="rect">
             <a:avLst/>
           </a:prstGeom>
           <a:solidFill>
-            <a:srgbClr val="FBBF24"/>
+            <a:srgbClr val="F87171"/>
           </a:solidFill>
           <a:ln>
             <a:noFill/>
@@ -10901,13 +10937,13 @@
       </p:sp>
       <p:sp>
         <p:nvSpPr>
-          <p:cNvPr id="110" name="TextBox 109"/>
+          <p:cNvPr id="111" name="TextBox 110"/>
           <p:cNvSpPr txBox="1"/>
           <p:nvPr/>
         </p:nvSpPr>
         <p:spPr>
           <a:xfrm>
-            <a:off x="4370831" y="5422392"/>
+            <a:off x="3090672" y="5422392"/>
             <a:ext cx="1097280" cy="228600"/>
           </a:xfrm>
           <a:prstGeom prst="rect">
@@ -10924,26 +10960,26 @@
             <a:pPr algn="l">
               <a:defRPr sz="800" b="1">
                 <a:solidFill>
-                  <a:srgbClr val="FBBF24"/>
+                  <a:srgbClr val="F87171"/>
                 </a:solidFill>
                 <a:latin typeface="Calibri"/>
               </a:defRPr>
             </a:pPr>
             <a:r>
-              <a:t>XSS Escaped</a:t>
-            </a:r>
-          </a:p>
-        </p:txBody>
-      </p:sp>
-      <p:sp>
-        <p:nvSpPr>
-          <p:cNvPr id="111" name="Rounded Rectangle 110"/>
+              <a:t>SSRF Block</a:t>
+            </a:r>
+          </a:p>
+        </p:txBody>
+      </p:sp>
+      <p:sp>
+        <p:nvSpPr>
+          <p:cNvPr id="112" name="Rounded Rectangle 111"/>
           <p:cNvSpPr/>
           <p:nvPr/>
         </p:nvSpPr>
         <p:spPr>
           <a:xfrm>
-            <a:off x="5577840" y="5349240"/>
+            <a:off x="4297679" y="5349240"/>
             <a:ext cx="1188720" cy="365760"/>
           </a:xfrm>
           <a:prstGeom prst="roundRect">
@@ -10980,20 +11016,20 @@
       </p:sp>
       <p:sp>
         <p:nvSpPr>
-          <p:cNvPr id="112" name="Rectangle 111"/>
+          <p:cNvPr id="113" name="Rectangle 112"/>
           <p:cNvSpPr/>
           <p:nvPr/>
         </p:nvSpPr>
         <p:spPr>
           <a:xfrm>
-            <a:off x="5577840" y="5349240"/>
+            <a:off x="4297679" y="5349240"/>
             <a:ext cx="1188720" cy="38100"/>
           </a:xfrm>
           <a:prstGeom prst="rect">
             <a:avLst/>
           </a:prstGeom>
           <a:solidFill>
-            <a:srgbClr val="A78BFA"/>
+            <a:srgbClr val="FBBF24"/>
           </a:solidFill>
           <a:ln>
             <a:noFill/>
@@ -11023,13 +11059,13 @@
       </p:sp>
       <p:sp>
         <p:nvSpPr>
-          <p:cNvPr id="113" name="TextBox 112"/>
+          <p:cNvPr id="114" name="TextBox 113"/>
           <p:cNvSpPr txBox="1"/>
           <p:nvPr/>
         </p:nvSpPr>
         <p:spPr>
           <a:xfrm>
-            <a:off x="5650992" y="5422392"/>
+            <a:off x="4370831" y="5422392"/>
             <a:ext cx="1097280" cy="228600"/>
           </a:xfrm>
           <a:prstGeom prst="rect">
@@ -11046,26 +11082,26 @@
             <a:pPr algn="l">
               <a:defRPr sz="800" b="1">
                 <a:solidFill>
-                  <a:srgbClr val="A78BFA"/>
+                  <a:srgbClr val="FBBF24"/>
                 </a:solidFill>
                 <a:latin typeface="Calibri"/>
               </a:defRPr>
             </a:pPr>
             <a:r>
-              <a:t>SOQL Safe</a:t>
-            </a:r>
-          </a:p>
-        </p:txBody>
-      </p:sp>
-      <p:sp>
-        <p:nvSpPr>
-          <p:cNvPr id="114" name="Rounded Rectangle 113"/>
+              <a:t>XSS Escaped</a:t>
+            </a:r>
+          </a:p>
+        </p:txBody>
+      </p:sp>
+      <p:sp>
+        <p:nvSpPr>
+          <p:cNvPr id="115" name="Rounded Rectangle 114"/>
           <p:cNvSpPr/>
           <p:nvPr/>
         </p:nvSpPr>
         <p:spPr>
           <a:xfrm>
-            <a:off x="6858000" y="5349240"/>
+            <a:off x="5577840" y="5349240"/>
             <a:ext cx="1188720" cy="365760"/>
           </a:xfrm>
           <a:prstGeom prst="roundRect">
@@ -11102,20 +11138,20 @@
       </p:sp>
       <p:sp>
         <p:nvSpPr>
-          <p:cNvPr id="115" name="Rectangle 114"/>
+          <p:cNvPr id="116" name="Rectangle 115"/>
           <p:cNvSpPr/>
           <p:nvPr/>
         </p:nvSpPr>
         <p:spPr>
           <a:xfrm>
-            <a:off x="6858000" y="5349240"/>
+            <a:off x="5577840" y="5349240"/>
             <a:ext cx="1188720" cy="38100"/>
           </a:xfrm>
           <a:prstGeom prst="rect">
             <a:avLst/>
           </a:prstGeom>
           <a:solidFill>
-            <a:srgbClr val="7C7FFF"/>
+            <a:srgbClr val="A78BFA"/>
           </a:solidFill>
           <a:ln>
             <a:noFill/>
@@ -11145,13 +11181,13 @@
       </p:sp>
       <p:sp>
         <p:nvSpPr>
-          <p:cNvPr id="116" name="TextBox 115"/>
+          <p:cNvPr id="117" name="TextBox 116"/>
           <p:cNvSpPr txBox="1"/>
           <p:nvPr/>
         </p:nvSpPr>
         <p:spPr>
           <a:xfrm>
-            <a:off x="6931152" y="5422392"/>
+            <a:off x="5650992" y="5422392"/>
             <a:ext cx="1097280" cy="228600"/>
           </a:xfrm>
           <a:prstGeom prst="rect">
@@ -11168,26 +11204,26 @@
             <a:pPr algn="l">
               <a:defRPr sz="800" b="1">
                 <a:solidFill>
-                  <a:srgbClr val="7C7FFF"/>
+                  <a:srgbClr val="A78BFA"/>
                 </a:solidFill>
                 <a:latin typeface="Calibri"/>
               </a:defRPr>
             </a:pPr>
             <a:r>
-              <a:t>CORS Locked</a:t>
-            </a:r>
-          </a:p>
-        </p:txBody>
-      </p:sp>
-      <p:sp>
-        <p:nvSpPr>
-          <p:cNvPr id="117" name="Rounded Rectangle 116"/>
+              <a:t>SOQL Safe</a:t>
+            </a:r>
+          </a:p>
+        </p:txBody>
+      </p:sp>
+      <p:sp>
+        <p:nvSpPr>
+          <p:cNvPr id="118" name="Rounded Rectangle 117"/>
           <p:cNvSpPr/>
           <p:nvPr/>
         </p:nvSpPr>
         <p:spPr>
           <a:xfrm>
-            <a:off x="8138159" y="5349240"/>
+            <a:off x="6858000" y="5349240"/>
             <a:ext cx="1188720" cy="365760"/>
           </a:xfrm>
           <a:prstGeom prst="roundRect">
@@ -11224,20 +11260,20 @@
       </p:sp>
       <p:sp>
         <p:nvSpPr>
-          <p:cNvPr id="118" name="Rectangle 117"/>
+          <p:cNvPr id="119" name="Rectangle 118"/>
           <p:cNvSpPr/>
           <p:nvPr/>
         </p:nvSpPr>
         <p:spPr>
           <a:xfrm>
-            <a:off x="8138159" y="5349240"/>
+            <a:off x="6858000" y="5349240"/>
             <a:ext cx="1188720" cy="38100"/>
           </a:xfrm>
           <a:prstGeom prst="rect">
             <a:avLst/>
           </a:prstGeom>
           <a:solidFill>
-            <a:srgbClr val="34D399"/>
+            <a:srgbClr val="7C7FFF"/>
           </a:solidFill>
           <a:ln>
             <a:noFill/>
@@ -11267,13 +11303,13 @@
       </p:sp>
       <p:sp>
         <p:nvSpPr>
-          <p:cNvPr id="119" name="TextBox 118"/>
+          <p:cNvPr id="120" name="TextBox 119"/>
           <p:cNvSpPr txBox="1"/>
           <p:nvPr/>
         </p:nvSpPr>
         <p:spPr>
           <a:xfrm>
-            <a:off x="8211311" y="5422392"/>
+            <a:off x="6931152" y="5422392"/>
             <a:ext cx="1097280" cy="228600"/>
           </a:xfrm>
           <a:prstGeom prst="rect">
@@ -11290,26 +11326,26 @@
             <a:pPr algn="l">
               <a:defRPr sz="800" b="1">
                 <a:solidFill>
-                  <a:srgbClr val="34D399"/>
+                  <a:srgbClr val="7C7FFF"/>
                 </a:solidFill>
                 <a:latin typeface="Calibri"/>
               </a:defRPr>
             </a:pPr>
             <a:r>
-              <a:t>Gmail OAuth</a:t>
-            </a:r>
-          </a:p>
-        </p:txBody>
-      </p:sp>
-      <p:sp>
-        <p:nvSpPr>
-          <p:cNvPr id="120" name="Rounded Rectangle 119"/>
+              <a:t>CORS Locked</a:t>
+            </a:r>
+          </a:p>
+        </p:txBody>
+      </p:sp>
+      <p:sp>
+        <p:nvSpPr>
+          <p:cNvPr id="121" name="Rounded Rectangle 120"/>
           <p:cNvSpPr/>
           <p:nvPr/>
         </p:nvSpPr>
         <p:spPr>
           <a:xfrm>
-            <a:off x="9418319" y="5349240"/>
+            <a:off x="8138159" y="5349240"/>
             <a:ext cx="1188720" cy="365760"/>
           </a:xfrm>
           <a:prstGeom prst="roundRect">
@@ -11346,20 +11382,20 @@
       </p:sp>
       <p:sp>
         <p:nvSpPr>
-          <p:cNvPr id="121" name="Rectangle 120"/>
+          <p:cNvPr id="122" name="Rectangle 121"/>
           <p:cNvSpPr/>
           <p:nvPr/>
         </p:nvSpPr>
         <p:spPr>
           <a:xfrm>
-            <a:off x="9418319" y="5349240"/>
+            <a:off x="8138159" y="5349240"/>
             <a:ext cx="1188720" cy="38100"/>
           </a:xfrm>
           <a:prstGeom prst="rect">
             <a:avLst/>
           </a:prstGeom>
           <a:solidFill>
-            <a:srgbClr val="60A5FA"/>
+            <a:srgbClr val="34D399"/>
           </a:solidFill>
           <a:ln>
             <a:noFill/>
@@ -11389,13 +11425,13 @@
       </p:sp>
       <p:sp>
         <p:nvSpPr>
-          <p:cNvPr id="122" name="TextBox 121"/>
+          <p:cNvPr id="123" name="TextBox 122"/>
           <p:cNvSpPr txBox="1"/>
           <p:nvPr/>
         </p:nvSpPr>
         <p:spPr>
           <a:xfrm>
-            <a:off x="9491471" y="5422392"/>
+            <a:off x="8211311" y="5422392"/>
             <a:ext cx="1097280" cy="228600"/>
           </a:xfrm>
           <a:prstGeom prst="rect">
@@ -11412,26 +11448,26 @@
             <a:pPr algn="l">
               <a:defRPr sz="800" b="1">
                 <a:solidFill>
-                  <a:srgbClr val="60A5FA"/>
+                  <a:srgbClr val="34D399"/>
                 </a:solidFill>
                 <a:latin typeface="Calibri"/>
               </a:defRPr>
             </a:pPr>
             <a:r>
-              <a:t>Salesforce OAuth</a:t>
-            </a:r>
-          </a:p>
-        </p:txBody>
-      </p:sp>
-      <p:sp>
-        <p:nvSpPr>
-          <p:cNvPr id="123" name="Rounded Rectangle 122"/>
+              <a:t>Gmail OAuth</a:t>
+            </a:r>
+          </a:p>
+        </p:txBody>
+      </p:sp>
+      <p:sp>
+        <p:nvSpPr>
+          <p:cNvPr id="124" name="Rounded Rectangle 123"/>
           <p:cNvSpPr/>
           <p:nvPr/>
         </p:nvSpPr>
         <p:spPr>
           <a:xfrm>
-            <a:off x="10698480" y="5349240"/>
+            <a:off x="9418319" y="5349240"/>
             <a:ext cx="1188720" cy="365760"/>
           </a:xfrm>
           <a:prstGeom prst="roundRect">
@@ -11468,20 +11504,20 @@
       </p:sp>
       <p:sp>
         <p:nvSpPr>
-          <p:cNvPr id="124" name="Rectangle 123"/>
+          <p:cNvPr id="125" name="Rectangle 124"/>
           <p:cNvSpPr/>
           <p:nvPr/>
         </p:nvSpPr>
         <p:spPr>
           <a:xfrm>
-            <a:off x="10698480" y="5349240"/>
+            <a:off x="9418319" y="5349240"/>
             <a:ext cx="1188720" cy="38100"/>
           </a:xfrm>
           <a:prstGeom prst="rect">
             <a:avLst/>
           </a:prstGeom>
           <a:solidFill>
-            <a:srgbClr val="A78BFA"/>
+            <a:srgbClr val="60A5FA"/>
           </a:solidFill>
           <a:ln>
             <a:noFill/>
@@ -11511,7 +11547,129 @@
       </p:sp>
       <p:sp>
         <p:nvSpPr>
-          <p:cNvPr id="125" name="TextBox 124"/>
+          <p:cNvPr id="126" name="TextBox 125"/>
+          <p:cNvSpPr txBox="1"/>
+          <p:nvPr/>
+        </p:nvSpPr>
+        <p:spPr>
+          <a:xfrm>
+            <a:off x="9491471" y="5422392"/>
+            <a:ext cx="1097280" cy="228600"/>
+          </a:xfrm>
+          <a:prstGeom prst="rect">
+            <a:avLst/>
+          </a:prstGeom>
+          <a:noFill/>
+        </p:spPr>
+        <p:txBody>
+          <a:bodyPr wrap="square">
+            <a:spAutoFit/>
+          </a:bodyPr>
+          <a:lstStyle/>
+          <a:p>
+            <a:pPr algn="l">
+              <a:defRPr sz="800" b="1">
+                <a:solidFill>
+                  <a:srgbClr val="60A5FA"/>
+                </a:solidFill>
+                <a:latin typeface="Calibri"/>
+              </a:defRPr>
+            </a:pPr>
+            <a:r>
+              <a:t>Salesforce OAuth</a:t>
+            </a:r>
+          </a:p>
+        </p:txBody>
+      </p:sp>
+      <p:sp>
+        <p:nvSpPr>
+          <p:cNvPr id="127" name="Rounded Rectangle 126"/>
+          <p:cNvSpPr/>
+          <p:nvPr/>
+        </p:nvSpPr>
+        <p:spPr>
+          <a:xfrm>
+            <a:off x="10698480" y="5349240"/>
+            <a:ext cx="1188720" cy="365760"/>
+          </a:xfrm>
+          <a:prstGeom prst="roundRect">
+            <a:avLst/>
+          </a:prstGeom>
+          <a:solidFill>
+            <a:srgbClr val="161718"/>
+          </a:solidFill>
+          <a:ln>
+            <a:noFill/>
+          </a:ln>
+        </p:spPr>
+        <p:style>
+          <a:lnRef idx="1">
+            <a:schemeClr val="accent1"/>
+          </a:lnRef>
+          <a:fillRef idx="3">
+            <a:schemeClr val="accent1"/>
+          </a:fillRef>
+          <a:effectRef idx="2">
+            <a:schemeClr val="accent1"/>
+          </a:effectRef>
+          <a:fontRef idx="minor">
+            <a:schemeClr val="lt1"/>
+          </a:fontRef>
+        </p:style>
+        <p:txBody>
+          <a:bodyPr rtlCol="0" anchor="ctr"/>
+          <a:lstStyle/>
+          <a:p>
+            <a:pPr algn="ctr"/>
+          </a:p>
+        </p:txBody>
+      </p:sp>
+      <p:sp>
+        <p:nvSpPr>
+          <p:cNvPr id="128" name="Rectangle 127"/>
+          <p:cNvSpPr/>
+          <p:nvPr/>
+        </p:nvSpPr>
+        <p:spPr>
+          <a:xfrm>
+            <a:off x="10698480" y="5349240"/>
+            <a:ext cx="1188720" cy="38100"/>
+          </a:xfrm>
+          <a:prstGeom prst="rect">
+            <a:avLst/>
+          </a:prstGeom>
+          <a:solidFill>
+            <a:srgbClr val="A78BFA"/>
+          </a:solidFill>
+          <a:ln>
+            <a:noFill/>
+          </a:ln>
+        </p:spPr>
+        <p:style>
+          <a:lnRef idx="1">
+            <a:schemeClr val="accent1"/>
+          </a:lnRef>
+          <a:fillRef idx="3">
+            <a:schemeClr val="accent1"/>
+          </a:fillRef>
+          <a:effectRef idx="2">
+            <a:schemeClr val="accent1"/>
+          </a:effectRef>
+          <a:fontRef idx="minor">
+            <a:schemeClr val="lt1"/>
+          </a:fontRef>
+        </p:style>
+        <p:txBody>
+          <a:bodyPr rtlCol="0" anchor="ctr"/>
+          <a:lstStyle/>
+          <a:p>
+            <a:pPr algn="ctr"/>
+          </a:p>
+        </p:txBody>
+      </p:sp>
+      <p:sp>
+        <p:nvSpPr>
+          <p:cNvPr id="129" name="TextBox 128"/>
           <p:cNvSpPr txBox="1"/>
           <p:nvPr/>
         </p:nvSpPr>

</xml_diff>